<commit_message>
presentations: the decks brought to v0.3.0 — fresh captures, the one-page board, the current CLI and numbers, what v0.2 and v0.3 delivered, the harness talk's measured-and-healed slide and registry policy (EN, FR); the stress-and-value deck in the Slides fonts
</commit_message>
<xml_diff>
--- a/presentations/agent-one-binary.pptx
+++ b/presentations/agent-one-binary.pptx
@@ -520,7 +520,7 @@
           <a:p>
             <a:r>
               <a:rPr lang="en-US" dirty="0"/>
-              <a:t>Title. AGENT-ONE v0.1.2: a single static Go binary. Everything shown in this deck is captured from the released binary running in a demo workspace against a scripted OpenAI-compatible server.</a:t>
+              <a:t>Title. AGENT-ONE v0.3.0: a single static Go binary. Everything shown in this deck is captured from the released binary running in a demo workspace against a scripted OpenAI-compatible server.</a:t>
             </a:r>
             <a:endParaRPr lang="en-US" dirty="0"/>
           </a:p>
@@ -960,7 +960,7 @@
           <a:p>
             <a:r>
               <a:rPr lang="en-US" dirty="0"/>
-              <a:t>Pages: Overview · Subagents · Usage · Team · Memory · Toolbox · Log · Config. Mobile first: the phone layout on the right. A page is proven by rendering it — that rule caught a rename that had silently broken the theme.</a:t>
+              <a:t>One page at the root with tabs: Overview (the neural net beside the console, the timeline under it) · Console · Neural net · Metrics · Subagents · Memory · Toolbox · Config. A click pins an agent's card over the net. Every read is guarded to a loopback host; acts need a token. Mobile first: the phone layout on the right.</a:t>
             </a:r>
             <a:endParaRPr lang="en-US" dirty="0"/>
           </a:p>
@@ -1048,7 +1048,7 @@
           <a:p>
             <a:r>
               <a:rPr lang="en-US" dirty="0"/>
-              <a:t>The graph is a fixture workspace with a coordinator, a domain owner and two zone workers; the config page is the demo workspace, showing webfetch switched off.</a:t>
+              <a:t>The graph is agent-one's own workspace: four lane coordinators, six domain owners, the zone workers and the skills they use.</a:t>
             </a:r>
             <a:endParaRPr lang="en-US" dirty="0"/>
           </a:p>
@@ -1312,7 +1312,7 @@
           <a:p>
             <a:r>
               <a:rPr lang="en-US" dirty="0"/>
-              <a:t>v0.2 lands by the same ladder: each layer green on its own tests before the next starts.</a:t>
+              <a:t>Every item landed by the same ladder: each layer green on its own tests before the next starts. v0.3.0 is the current release; the CHANGELOG has the full list.</a:t>
             </a:r>
             <a:endParaRPr lang="en-US" dirty="0"/>
           </a:p>
@@ -2651,7 +2651,7 @@
                 <a:ea typeface="Courier New" pitchFamily="34" charset="-122"/>
                 <a:cs typeface="Courier New" pitchFamily="34" charset="-120"/>
               </a:rPr>
-              <a:t>v0.1.2  ·  github.com/Kaginari/agent-one</a:t>
+              <a:t>v0.3.0  ·  github.com/Kaginari/agent-one</a:t>
             </a:r>
             <a:endParaRPr lang="en-US" sz="1100" dirty="0"/>
           </a:p>
@@ -3281,7 +3281,7 @@
                 <a:ea typeface="Courier New" pitchFamily="34" charset="-122"/>
                 <a:cs typeface="Courier New" pitchFamily="34" charset="-120"/>
               </a:rPr>
-              <a:t>memory — world-agent-one · as orchestrator</a:t>
+              <a:t>memory — demo · as orchestrator</a:t>
             </a:r>
             <a:endParaRPr lang="en-US" sz="950" dirty="0"/>
           </a:p>
@@ -3321,7 +3321,7 @@
                 <a:ea typeface="Courier New" pitchFamily="34" charset="-122"/>
                 <a:cs typeface="Courier New" pitchFamily="34" charset="-120"/>
               </a:rPr>
-              <a:t>        working 0 workingNotess</a:t>
+              <a:t>        working 0 note sets</a:t>
             </a:r>
             <a:endParaRPr lang="en-US" sz="950" dirty="0"/>
           </a:p>
@@ -3341,7 +3341,7 @@
                 <a:ea typeface="Courier New" pitchFamily="34" charset="-122"/>
                 <a:cs typeface="Courier New" pitchFamily="34" charset="-120"/>
               </a:rPr>
-              <a:t>        cache   3 recalls cached, 2 hits  (.agent-one/memor…</a:t>
+              <a:t>        cache   2 recalls cached, 4 hits  (.agent-one/memor…</a:t>
             </a:r>
             <a:endParaRPr lang="en-US" sz="950" dirty="0"/>
           </a:p>
@@ -3361,7 +3361,7 @@
                 <a:ea typeface="Courier New" pitchFamily="34" charset="-122"/>
                 <a:cs typeface="Courier New" pitchFamily="34" charset="-120"/>
               </a:rPr>
-              <a:t>LONG    episodic 1 · procedural 0 · semantic 17  (built 202…</a:t>
+              <a:t>LONG    episodic 2 · procedural 0 · semantic 18  (built 202…</a:t>
             </a:r>
             <a:endParaRPr lang="en-US" sz="950" dirty="0"/>
           </a:p>
@@ -3401,7 +3401,7 @@
                 <a:ea typeface="Courier New" pitchFamily="34" charset="-122"/>
                 <a:cs typeface="Courier New" pitchFamily="34" charset="-120"/>
               </a:rPr>
-              <a:t>@? index older than its sources — 1 changed: .agent-one/log…</a:t>
+              <a:t>@? context window unmeasured — no Claude Code transcripts f…</a:t>
             </a:r>
             <a:endParaRPr lang="en-US" sz="950" dirty="0"/>
           </a:p>
@@ -4213,7 +4213,7 @@
                 <a:ea typeface="Courier New" pitchFamily="34" charset="-122"/>
                 <a:cs typeface="Courier New" pitchFamily="34" charset="-120"/>
               </a:rPr>
-              <a:t>$ agent-one toolbox brief "edit a file and run the tests"</a:t>
+              <a:t>$ agent-one toolbox brief "add a login endpoint with tests"</a:t>
             </a:r>
             <a:endParaRPr lang="en-US" sz="900" dirty="0"/>
           </a:p>
@@ -4318,7 +4318,7 @@
                 <a:ea typeface="Calibri" pitchFamily="34" charset="-122"/>
                 <a:cs typeface="Calibri" pitchFamily="34" charset="-120"/>
               </a:rPr>
-              <a:t>Default toolset (max): bash, read/ls/glob/grep, write/edit/multiedit/patch, git, webfetch, websearch, ask, dispatch, recall/remember, toolbox, onto, skill, MCP.</a:t>
+              <a:t>Default toolset (max): bash, read/ls/glob/grep, write/edit/multiedit/patch/delete, git, webfetch, websearch, ask, dispatch, plan, desk, recall/remember, toolbox, onto, skill, pulse, MCP.</a:t>
             </a:r>
             <a:endParaRPr lang="en-US" sz="1250" dirty="0"/>
           </a:p>
@@ -5742,7 +5742,7 @@
                 <a:ea typeface="Courier New" pitchFamily="34" charset="-122"/>
                 <a:cs typeface="Courier New" pitchFamily="34" charset="-120"/>
               </a:rPr>
-              <a:t>usage: 4 calls · 2 sessions · in 5400 (cache read 0, write 0) · out 1…</a:t>
+              <a:t>usage: 6 calls · 3 sessions · in 8100 (cache read 0, write 0) · out 2…</a:t>
             </a:r>
             <a:endParaRPr lang="en-US" sz="1000" dirty="0"/>
           </a:p>
@@ -5782,7 +5782,7 @@
                 <a:ea typeface="Courier New" pitchFamily="34" charset="-122"/>
                 <a:cs typeface="Courier New" pitchFamily="34" charset="-120"/>
               </a:rPr>
-              <a:t>  orchestrator                   4 calls  in     5400  out     160  $…</a:t>
+              <a:t>  orchestrator                   6 calls  in     8100  out     240  $…</a:t>
             </a:r>
             <a:endParaRPr lang="en-US" sz="1000" dirty="0"/>
           </a:p>
@@ -5822,7 +5822,7 @@
                 <a:ea typeface="Courier New" pitchFamily="34" charset="-122"/>
                 <a:cs typeface="Courier New" pitchFamily="34" charset="-120"/>
               </a:rPr>
-              <a:t>  —                              4 calls  in     5400  out     160  $…</a:t>
+              <a:t>  —                              6 calls  in     8100  out     240  $…</a:t>
             </a:r>
             <a:endParaRPr lang="en-US" sz="1000" dirty="0"/>
           </a:p>
@@ -5862,7 +5862,7 @@
                 <a:ea typeface="Courier New" pitchFamily="34" charset="-122"/>
                 <a:cs typeface="Courier New" pitchFamily="34" charset="-120"/>
               </a:rPr>
-              <a:t>  orchestrator                   4 calls  in     5400  out     160  $…</a:t>
+              <a:t>  orchestrator                   6 calls  in     8100  out     240  $…</a:t>
             </a:r>
             <a:endParaRPr lang="en-US" sz="1000" dirty="0"/>
           </a:p>
@@ -5902,7 +5902,7 @@
                 <a:ea typeface="Courier New" pitchFamily="34" charset="-122"/>
                 <a:cs typeface="Courier New" pitchFamily="34" charset="-120"/>
               </a:rPr>
-              <a:t>  vllm/fake/vllm-coder           4 calls  in     5400  out     160  $…</a:t>
+              <a:t>  vllm/fake/vllm-coder           6 calls  in     8100  out     240  $…</a:t>
             </a:r>
             <a:endParaRPr lang="en-US" sz="1000" dirty="0"/>
           </a:p>
@@ -5942,7 +5942,7 @@
                 <a:ea typeface="Courier New" pitchFamily="34" charset="-122"/>
                 <a:cs typeface="Courier New" pitchFamily="34" charset="-120"/>
               </a:rPr>
-              <a:t>  2026-09-26                     4 calls  in     5400  out     160  $…</a:t>
+              <a:t>  2026-10-11                     6 calls  in     8100  out     240  $…</a:t>
             </a:r>
             <a:endParaRPr lang="en-US" sz="1000" dirty="0"/>
           </a:p>
@@ -6275,7 +6275,7 @@
                 <a:ea typeface="Calibri" pitchFamily="34" charset="-122"/>
                 <a:cs typeface="Calibri" pitchFamily="34" charset="-120"/>
               </a:rPr>
-              <a:t>Served by the binary on localhost · eight pages on the Bootstrap grid · live over SSE · dark and light.</a:t>
+              <a:t>One page on localhost · the neural net in 2D and 3D, metrics, court, memory, toolbox, config · live over SSE · eight themes shared with the terminal.</a:t>
             </a:r>
             <a:endParaRPr lang="en-US" sz="1400" dirty="0"/>
           </a:p>
@@ -6577,7 +6577,7 @@
                 <a:ea typeface="Calibri" pitchFamily="34" charset="-122"/>
                 <a:cs typeface="Calibri" pitchFamily="34" charset="-120"/>
               </a:rPr>
-              <a:t>The Team page draws who owns what and how knowledge flows; Config shows each value and the layer it came from.</a:t>
+              <a:t>The neural net draws who owns what and how work flows; Config shows each value, the layer it came from, and what it does.</a:t>
             </a:r>
             <a:endParaRPr lang="en-US" sz="1400" dirty="0"/>
           </a:p>
@@ -6734,7 +6734,7 @@
                 <a:ea typeface="Calibri" pitchFamily="34" charset="-122"/>
                 <a:cs typeface="Calibri" pitchFamily="34" charset="-120"/>
               </a:rPr>
-              <a:t>Lanes by rank; typed, coloured links: ground truth up to the gate holder, verdicts up to the coordinator.</a:t>
+              <a:t>Lanes by rank; each tile four weeks of work; typed links: ground truth up to the gate holder, verdicts up to the coordinator.</a:t>
             </a:r>
             <a:endParaRPr lang="en-US" sz="1300" dirty="0"/>
           </a:p>
@@ -6755,7 +6755,7 @@
                 <a:ea typeface="Calibri" pitchFamily="34" charset="-122"/>
                 <a:cs typeface="Calibri" pitchFamily="34" charset="-120"/>
               </a:rPr>
-              <a:t>Click a node: its neighbours light up, its doc opens beside the graph.</a:t>
+              <a:t>Click a node: its path lights up, its card floats over the net — who it answers to, what it owns, its skills, its value.</a:t>
             </a:r>
             <a:endParaRPr lang="en-US" sz="1300" dirty="0"/>
           </a:p>
@@ -6776,7 +6776,7 @@
                 <a:ea typeface="Calibri" pitchFamily="34" charset="-122"/>
                 <a:cs typeface="Calibri" pitchFamily="34" charset="-120"/>
               </a:rPr>
-              <a:t>The off-list names every disabled feature with the file and line that did it.</a:t>
+              <a:t>Every key carries a line saying what it does; the off-list names every disabled feature with its file and line.</a:t>
             </a:r>
             <a:endParaRPr lang="en-US" sz="1300" dirty="0"/>
           </a:p>
@@ -7003,7 +7003,7 @@
                 <a:ea typeface="Cambria" pitchFamily="34" charset="-122"/>
                 <a:cs typeface="Cambria" pitchFamily="34" charset="-120"/>
               </a:rPr>
-              <a:t>195</a:t>
+              <a:t>201</a:t>
             </a:r>
             <a:endParaRPr lang="en-US" sz="4800" dirty="0"/>
           </a:p>
@@ -7081,7 +7081,7 @@
                 <a:ea typeface="Cambria" pitchFamily="34" charset="-122"/>
                 <a:cs typeface="Cambria" pitchFamily="34" charset="-120"/>
               </a:rPr>
-              <a:t>23</a:t>
+              <a:t>29</a:t>
             </a:r>
             <a:endParaRPr lang="en-US" sz="4800" dirty="0"/>
           </a:p>
@@ -7159,7 +7159,7 @@
                 <a:ea typeface="Cambria" pitchFamily="34" charset="-122"/>
                 <a:cs typeface="Cambria" pitchFamily="34" charset="-120"/>
               </a:rPr>
-              <a:t>9 + 8</a:t>
+              <a:t>654</a:t>
             </a:r>
             <a:endParaRPr lang="en-US" sz="4800" dirty="0"/>
           </a:p>
@@ -7198,7 +7198,7 @@
                 <a:ea typeface="Calibri" pitchFamily="34" charset="-122"/>
                 <a:cs typeface="Calibri" pitchFamily="34" charset="-120"/>
               </a:rPr>
-              <a:t>defects fixed: by attack, then by using the releases</a:t>
+              <a:t>test functions</a:t>
             </a:r>
             <a:endParaRPr lang="en-US" sz="1400" dirty="0"/>
           </a:p>
@@ -7361,7 +7361,28 @@
                 <a:ea typeface="Calibri" pitchFamily="34" charset="-122"/>
                 <a:cs typeface="Calibri" pitchFamily="34" charset="-120"/>
               </a:rPr>
-              <a:t>Honest limits: providers' streaming, caching and fallbacks are tested against local fakes only — not yet live.</a:t>
+              <a:t>The terminal's own tests drive the real host on a scripted model: twenty runs in a row green, and the README's screens come from them.</a:t>
+            </a:r>
+            <a:endParaRPr lang="en-US" sz="1500" dirty="0"/>
+          </a:p>
+          <a:p>
+            <a:pPr marL="342900" indent="-342900">
+              <a:spcAft>
+                <a:spcPts val="800"/>
+              </a:spcAft>
+              <a:buSzPct val="100000"/>
+              <a:buChar char="•"/>
+            </a:pPr>
+            <a:r>
+              <a:rPr lang="en-US" sz="1500" dirty="0">
+                <a:solidFill>
+                  <a:srgbClr val="A9B8C9"/>
+                </a:solidFill>
+                <a:latin typeface="Calibri" pitchFamily="34" charset="0"/>
+                <a:ea typeface="Calibri" pitchFamily="34" charset="-122"/>
+                <a:cs typeface="Calibri" pitchFamily="34" charset="-120"/>
+              </a:rPr>
+              <a:t>Honest limits: providers' streaming, caching and fallbacks are tested against local fakes; live runs are free OpenRouter models.</a:t>
             </a:r>
             <a:endParaRPr lang="en-US" sz="1500" dirty="0"/>
           </a:p>
@@ -8308,7 +8329,7 @@
                 <a:ea typeface="Cambria" pitchFamily="34" charset="-122"/>
                 <a:cs typeface="Cambria" pitchFamily="34" charset="-120"/>
               </a:rPr>
-              <a:t>Next: v0.2</a:t>
+              <a:t>Since v0.1: what v0.2 and v0.3 delivered</a:t>
             </a:r>
             <a:endParaRPr lang="en-US" sz="3000" dirty="0"/>
           </a:p>
@@ -8347,7 +8368,7 @@
                 <a:ea typeface="Calibri" pitchFamily="34" charset="-122"/>
                 <a:cs typeface="Calibri" pitchFamily="34" charset="-120"/>
               </a:rPr>
-              <a:t>Specified, not built yet.</a:t>
+              <a:t>The roadmap of v0.1, shipped — and what grew around it.</a:t>
             </a:r>
             <a:endParaRPr lang="en-US" sz="1400" dirty="0"/>
           </a:p>
@@ -8362,11 +8383,11 @@
         <p:spPr>
           <a:xfrm>
             <a:off x="548640" y="1737360"/>
-            <a:ext cx="3566160" cy="3017520"/>
+            <a:ext cx="3566160" cy="3154680"/>
           </a:xfrm>
           <a:prstGeom prst="roundRect">
             <a:avLst>
-              <a:gd name="adj" fmla="val 3030"/>
+              <a:gd name="adj" fmla="val 2899"/>
             </a:avLst>
           </a:prstGeom>
           <a:solidFill>
@@ -8455,7 +8476,7 @@
         <p:spPr>
           <a:xfrm>
             <a:off x="777240" y="2359152"/>
-            <a:ext cx="3108960" cy="2240280"/>
+            <a:ext cx="3108960" cy="2377440"/>
           </a:xfrm>
           <a:prstGeom prst="rect">
             <a:avLst/>
@@ -8474,7 +8495,7 @@
               <a:buNone/>
             </a:pPr>
             <a:r>
-              <a:rPr lang="en-US" sz="1350" dirty="0">
+              <a:rPr lang="en-US" sz="1250" dirty="0">
                 <a:solidFill>
                   <a:srgbClr val="3B4656"/>
                 </a:solidFill>
@@ -8482,9 +8503,9 @@
                 <a:ea typeface="Calibri" pitchFamily="34" charset="-122"/>
                 <a:cs typeface="Calibri" pitchFamily="34" charset="-120"/>
               </a:rPr>
-              <a:t>Install anything inside a disposable container; your repo, the network and pushes stay gated. Builds via rootless BuildKit — never the host Docker socket.</a:t>
-            </a:r>
-            <a:endParaRPr lang="en-US" sz="1350" dirty="0"/>
+              <a:t>--docker-agent runs the whole binary in a container: the workspace read-write, the rest read-only. A full runtime image (Go, Node, Python, build tools, Chromium) is published; the sandbox hides host processes and credentials, Seatbelt on macOS.</a:t>
+            </a:r>
+            <a:endParaRPr lang="en-US" sz="1250" dirty="0"/>
           </a:p>
         </p:txBody>
       </p:sp>
@@ -8497,11 +8518,11 @@
         <p:spPr>
           <a:xfrm>
             <a:off x="4297680" y="1737360"/>
-            <a:ext cx="3566160" cy="3017520"/>
+            <a:ext cx="3566160" cy="3154680"/>
           </a:xfrm>
           <a:prstGeom prst="roundRect">
             <a:avLst>
-              <a:gd name="adj" fmla="val 3030"/>
+              <a:gd name="adj" fmla="val 2899"/>
             </a:avLst>
           </a:prstGeom>
           <a:solidFill>
@@ -8575,7 +8596,7 @@
                 <a:ea typeface="Cambria" pitchFamily="34" charset="-122"/>
                 <a:cs typeface="Cambria" pitchFamily="34" charset="-120"/>
               </a:rPr>
-              <a:t>Enterprise registries &amp; proxy</a:t>
+              <a:t>Enterprise registries</a:t>
             </a:r>
             <a:endParaRPr lang="en-US" sz="1500" dirty="0"/>
           </a:p>
@@ -8590,7 +8611,7 @@
         <p:spPr>
           <a:xfrm>
             <a:off x="4526280" y="2359152"/>
-            <a:ext cx="3108960" cy="2240280"/>
+            <a:ext cx="3108960" cy="2377440"/>
           </a:xfrm>
           <a:prstGeom prst="rect">
             <a:avLst/>
@@ -8609,7 +8630,7 @@
               <a:buNone/>
             </a:pPr>
             <a:r>
-              <a:rPr lang="en-US" sz="1350" dirty="0">
+              <a:rPr lang="en-US" sz="1250" dirty="0">
                 <a:solidFill>
                   <a:srgbClr val="3B4656"/>
                 </a:solidFill>
@@ -8617,9 +8638,9 @@
                 <a:ea typeface="Calibri" pitchFamily="34" charset="-122"/>
                 <a:cs typeface="Calibri" pitchFamily="34" charset="-120"/>
               </a:rPr>
-              <a:t>Artifactory, GitLab, Nexus for docker, go, pypi, npm, cargo, maven; corporate proxy and CA everywhere; later a token-injecting egress proxy so no secret enters the container.</a:t>
-            </a:r>
-            <a:endParaRPr lang="en-US" sz="1350" dirty="0"/>
+              <a:t>registry: models from a gateway, tools for the toolbox, npm · pip · go logins, a private container registry — and policy private-only, which refuses a command that fetches packages from anywhere else.</a:t>
+            </a:r>
+            <a:endParaRPr lang="en-US" sz="1250" dirty="0"/>
           </a:p>
         </p:txBody>
       </p:sp>
@@ -8632,11 +8653,11 @@
         <p:spPr>
           <a:xfrm>
             <a:off x="8046720" y="1737360"/>
-            <a:ext cx="3566160" cy="3017520"/>
+            <a:ext cx="3566160" cy="3154680"/>
           </a:xfrm>
           <a:prstGeom prst="roundRect">
             <a:avLst>
-              <a:gd name="adj" fmla="val 3030"/>
+              <a:gd name="adj" fmla="val 2899"/>
             </a:avLst>
           </a:prstGeom>
           <a:solidFill>
@@ -8710,7 +8731,7 @@
                 <a:ea typeface="Cambria" pitchFamily="34" charset="-122"/>
                 <a:cs typeface="Cambria" pitchFamily="34" charset="-120"/>
               </a:rPr>
-              <a:t>Workspaces and systems</a:t>
+              <a:t>Measured, answered, healed</a:t>
             </a:r>
             <a:endParaRPr lang="en-US" sz="1500" dirty="0"/>
           </a:p>
@@ -8725,7 +8746,7 @@
         <p:spPr>
           <a:xfrm>
             <a:off x="8275320" y="2359152"/>
-            <a:ext cx="3108960" cy="2240280"/>
+            <a:ext cx="3108960" cy="2377440"/>
           </a:xfrm>
           <a:prstGeom prst="rect">
             <a:avLst/>
@@ -8744,7 +8765,7 @@
               <a:buNone/>
             </a:pPr>
             <a:r>
-              <a:rPr lang="en-US" sz="1350" dirty="0">
+              <a:rPr lang="en-US" sz="1250" dirty="0">
                 <a:solidFill>
                   <a:srgbClr val="3B4656"/>
                 </a:solidFill>
@@ -8752,9 +8773,9 @@
                 <a:ea typeface="Calibri" pitchFamily="34" charset="-122"/>
                 <a:cs typeface="Calibri" pitchFamily="34" charset="-120"/>
               </a:rPr>
-              <a:t>Nested workspaces are sovereign; systems group workspaces (app · deploy · infra) with typed, learned relations; one hop per level; the dashboard opens on the map.</a:t>
-            </a:r>
-            <a:endParaRPr lang="en-US" sz="1350" dirty="0"/>
+              <a:t>Each rank valued by its own job (meters on both faces); a strained agent draws the council, then relief, then evolution — split, mutate, rebirth — proven before it lands. The forge mints the skills a run proved.</a:t>
+            </a:r>
+            <a:endParaRPr lang="en-US" sz="1250" dirty="0"/>
           </a:p>
         </p:txBody>
       </p:sp>
@@ -8766,7 +8787,7 @@
         </p:nvSpPr>
         <p:spPr>
           <a:xfrm>
-            <a:off x="548640" y="5074920"/>
+            <a:off x="548640" y="5120640"/>
             <a:ext cx="11091672" cy="822960"/>
           </a:xfrm>
           <a:prstGeom prst="rect">
@@ -8791,7 +8812,7 @@
                 <a:ea typeface="Calibri" pitchFamily="34" charset="-122"/>
                 <a:cs typeface="Calibri" pitchFamily="34" charset="-120"/>
               </a:rPr>
-              <a:t>Each lands by the ladder: a layer is done only when its own tests pass against mocks of the layer below, and the next layer opens with an integration test of the two.</a:t>
+              <a:t>Next: the forge's second slice (minted tools proven in the sandbox), cargo and maven logins, a token-injecting egress proxy so no secret enters the container.</a:t>
             </a:r>
             <a:endParaRPr lang="en-US" sz="1500" dirty="0"/>
           </a:p>
@@ -8964,7 +8985,7 @@
                 <a:ea typeface="Cambria" pitchFamily="34" charset="-122"/>
                 <a:cs typeface="Cambria" pitchFamily="34" charset="-120"/>
               </a:rPr>
-              <a:t>AGENT-ONE v0.1.2</a:t>
+              <a:t>AGENT-ONE v0.3.0</a:t>
             </a:r>
             <a:endParaRPr lang="en-US" sz="4000" dirty="0"/>
           </a:p>
@@ -12770,7 +12791,7 @@
                 <a:ea typeface="Courier New" pitchFamily="34" charset="-122"/>
                 <a:cs typeface="Courier New" pitchFamily="34" charset="-120"/>
               </a:rPr>
-              <a:t>  ok (21ms) wrote hello.txt</a:t>
+              <a:t>  ok (17ms) wrote hello.txt</a:t>
             </a:r>
             <a:endParaRPr lang="en-US" sz="1100" dirty="0"/>
           </a:p>
@@ -12965,7 +12986,7 @@
                 <a:ea typeface="Courier New" pitchFamily="34" charset="-122"/>
                 <a:cs typeface="Courier New" pitchFamily="34" charset="-120"/>
               </a:rPr>
-              <a:t>### [2026-09-26T15:36:11+02:00] orchestrator — Gate: n/a (no domain owners) —…</a:t>
+              <a:t>### [2026-10-11T12:12:41+02:00] orchestrator — Gate: n/a (no domain owners) —…</a:t>
             </a:r>
             <a:endParaRPr lang="en-US" sz="1100" dirty="0"/>
           </a:p>
@@ -13359,7 +13380,7 @@
                 <a:ea typeface="Calibri" pitchFamily="34" charset="-122"/>
                 <a:cs typeface="Calibri" pitchFamily="34" charset="-120"/>
               </a:rPr>
-              <a:t>The scripted model tried to write outside the workspace. Nobody was there to approve it.</a:t>
+              <a:t>The scripted model tried to write outside the workspace — refused before anyone was asked.</a:t>
             </a:r>
             <a:endParaRPr lang="en-US" sz="1400" dirty="0"/>
           </a:p>
@@ -13432,7 +13453,7 @@
                 <a:ea typeface="Courier New" pitchFamily="34" charset="-122"/>
                 <a:cs typeface="Courier New" pitchFamily="34" charset="-120"/>
               </a:rPr>
-              <a:t>$ agent-one run "Create the file /app/hello.txt with hello bench"</a:t>
+              <a:t>$ agent-one run "Create hello.txt with the line: hello bench"   # the model aims at /app/hello.txt</a:t>
             </a:r>
             <a:endParaRPr lang="en-US" sz="900" dirty="0"/>
           </a:p>
@@ -13474,7 +13495,7 @@
                 <a:ea typeface="Courier New" pitchFamily="34" charset="-122"/>
                 <a:cs typeface="Courier New" pitchFamily="34" charset="-120"/>
               </a:rPr>
-              <a:t>✗ s1 bash [outward] denied at the gate (path outside the workspace: /app/hello.txt; no TTY to ask — pass --approve outward to p…</a:t>
+              <a:t>✗ s1 bash refused by the guard</a:t>
             </a:r>
             <a:endParaRPr lang="en-US" sz="1050" dirty="0"/>
           </a:p>
@@ -13494,7 +13515,7 @@
                 <a:ea typeface="Courier New" pitchFamily="34" charset="-122"/>
                 <a:cs typeface="Courier New" pitchFamily="34" charset="-120"/>
               </a:rPr>
-              <a:t>@? s1 denied at the gate (outward: path outside the workspace: /app/hello.txt; no TTY to ask — pass --approve outward to pre-ap…</a:t>
+              <a:t>@S DONE wrote /app/hello.txt</a:t>
             </a:r>
             <a:endParaRPr lang="en-US" sz="1050" dirty="0"/>
           </a:p>
@@ -13514,7 +13535,7 @@
                 <a:ea typeface="Courier New" pitchFamily="34" charset="-122"/>
                 <a:cs typeface="Courier New" pitchFamily="34" charset="-120"/>
               </a:rPr>
-              <a:t>agent-one · vllm/fake/vllm-coder · ctx 0% (OK) · 1240 tok · $0.0003</a:t>
+              <a:t>@E 30</a:t>
             </a:r>
             <a:endParaRPr lang="en-US" sz="1050" dirty="0"/>
           </a:p>
@@ -13795,6 +13816,27 @@
         <p:txBody>
           <a:bodyPr wrap="square" lIns="0" tIns="0" rIns="0" bIns="0" rtlCol="0" anchor="t"/>
           <a:lstStyle/>
+          <a:p>
+            <a:pPr marL="342900" indent="-342900">
+              <a:spcAft>
+                <a:spcPts val="800"/>
+              </a:spcAft>
+              <a:buSzPct val="100000"/>
+              <a:buChar char="•"/>
+            </a:pPr>
+            <a:r>
+              <a:rPr lang="en-US" sz="1300" dirty="0">
+                <a:solidFill>
+                  <a:srgbClr val="3B4656"/>
+                </a:solidFill>
+                <a:latin typeface="Calibri" pitchFamily="34" charset="0"/>
+                <a:ea typeface="Calibri" pitchFamily="34" charset="-122"/>
+                <a:cs typeface="Calibri" pitchFamily="34" charset="-120"/>
+              </a:rPr>
+              <a:t>A write that leaves the workspace is refused by the guard before any approval — scratch lives in the workspace (tools.tmpRedirect).</a:t>
+            </a:r>
+            <a:endParaRPr lang="en-US" sz="1300" dirty="0"/>
+          </a:p>
           <a:p>
             <a:pPr marL="342900" indent="-342900">
               <a:spcAft>
@@ -14095,7 +14137,7 @@
                 <a:gridCol w="2514600"/>
                 <a:gridCol w="3794760"/>
               </a:tblGrid>
-              <a:tr h="429768">
+              <a:tr h="393192">
                 <a:tc>
                   <a:txBody>
                     <a:bodyPr/>
@@ -14233,7 +14275,7 @@
                   </a:tcPr>
                 </a:tc>
               </a:tr>
-              <a:tr h="429768">
+              <a:tr h="393192">
                 <a:tc>
                   <a:txBody>
                     <a:bodyPr/>
@@ -14251,7 +14293,7 @@
                           <a:ea typeface="Courier New" pitchFamily="34" charset="-122"/>
                           <a:cs typeface="Courier New" pitchFamily="34" charset="-120"/>
                         </a:rPr>
-                        <a:t>agent-one repl (default)</a:t>
+                        <a:t>agent-one repl (default) · dash</a:t>
                       </a:r>
                       <a:endParaRPr lang="en-US" sz="1100" dirty="0">
                         <a:latin typeface="Courier New" charset="0"/>
@@ -14319,7 +14361,7 @@
                           <a:ea typeface="Calibri" pitchFamily="34" charset="-122"/>
                           <a:cs typeface="Calibri" pitchFamily="34" charset="-120"/>
                         </a:rPr>
-                        <a:t>the live session — talk while ephemeral subagents work; /agents /send /usage /status /compact</a:t>
+                        <a:t>the live session in the terminal, or beside it in the browser; /theme /settings /forge /status</a:t>
                       </a:r>
                       <a:endParaRPr lang="en-US" sz="1200" dirty="0">
                         <a:latin typeface="Calibri" charset="0"/>
@@ -14371,7 +14413,7 @@
                   </a:tcPr>
                 </a:tc>
               </a:tr>
-              <a:tr h="429768">
+              <a:tr h="393192">
                 <a:tc>
                   <a:txBody>
                     <a:bodyPr/>
@@ -14509,7 +14551,7 @@
                   </a:tcPr>
                 </a:tc>
               </a:tr>
-              <a:tr h="429768">
+              <a:tr h="393192">
                 <a:tc>
                   <a:txBody>
                     <a:bodyPr/>
@@ -14527,7 +14569,7 @@
                           <a:ea typeface="Courier New" pitchFamily="34" charset="-122"/>
                           <a:cs typeface="Courier New" pitchFamily="34" charset="-120"/>
                         </a:rPr>
-                        <a:t>agent-one resume · sessions</a:t>
+                        <a:t>agent-one resume · goal · review</a:t>
                       </a:r>
                       <a:endParaRPr lang="en-US" sz="1100" dirty="0">
                         <a:latin typeface="Courier New" charset="0"/>
@@ -14595,7 +14637,7 @@
                           <a:ea typeface="Calibri" pitchFamily="34" charset="-122"/>
                           <a:cs typeface="Calibri" pitchFamily="34" charset="-120"/>
                         </a:rPr>
-                        <a:t>continue or list sessions (JSONL on disk)</a:t>
+                        <a:t>continue a session · work until a command proves it · two reviewers, one shortlist</a:t>
                       </a:r>
                       <a:endParaRPr lang="en-US" sz="1200" dirty="0">
                         <a:latin typeface="Calibri" charset="0"/>
@@ -14647,7 +14689,7 @@
                   </a:tcPr>
                 </a:tc>
               </a:tr>
-              <a:tr h="429768">
+              <a:tr h="393192">
                 <a:tc>
                   <a:txBody>
                     <a:bodyPr/>
@@ -14785,7 +14827,7 @@
                   </a:tcPr>
                 </a:tc>
               </a:tr>
-              <a:tr h="429768">
+              <a:tr h="393192">
                 <a:tc>
                   <a:txBody>
                     <a:bodyPr/>
@@ -14923,7 +14965,7 @@
                   </a:tcPr>
                 </a:tc>
               </a:tr>
-              <a:tr h="429768">
+              <a:tr h="393192">
                 <a:tc>
                   <a:txBody>
                     <a:bodyPr/>
@@ -15061,7 +15103,7 @@
                   </a:tcPr>
                 </a:tc>
               </a:tr>
-              <a:tr h="429768">
+              <a:tr h="393192">
                 <a:tc>
                   <a:txBody>
                     <a:bodyPr/>
@@ -15199,7 +15241,145 @@
                   </a:tcPr>
                 </a:tc>
               </a:tr>
-              <a:tr h="429768">
+              <a:tr h="393192">
+                <a:tc>
+                  <a:txBody>
+                    <a:bodyPr/>
+                    <a:lstStyle/>
+                    <a:p>
+                      <a:pPr indent="0" marL="0">
+                        <a:buNone/>
+                      </a:pPr>
+                      <a:r>
+                        <a:rPr lang="en-US" sz="1100" b="1" dirty="0">
+                          <a:solidFill>
+                            <a:srgbClr val="1F6F8B"/>
+                          </a:solidFill>
+                          <a:latin typeface="Courier New" pitchFamily="34" charset="0"/>
+                          <a:ea typeface="Courier New" pitchFamily="34" charset="-122"/>
+                          <a:cs typeface="Courier New" pitchFamily="34" charset="-120"/>
+                        </a:rPr>
+                        <a:t>agent-one forge · evolve</a:t>
+                      </a:r>
+                      <a:endParaRPr lang="en-US" sz="1100" dirty="0">
+                        <a:latin typeface="Courier New" charset="0"/>
+                        <a:ea typeface="Courier New" charset="0"/>
+                        <a:cs typeface="Courier New" charset="0"/>
+                      </a:endParaRPr>
+                    </a:p>
+                  </a:txBody>
+                  <a:tcPr marL="54864" marR="54864" marT="54864" marB="54864" anchor="ctr">
+                    <a:lnL w="9525" cap="flat" cmpd="sng" algn="ctr">
+                      <a:solidFill>
+                        <a:srgbClr val="DCE3EC"/>
+                      </a:solidFill>
+                      <a:prstDash val="solid"/>
+                      <a:round/>
+                      <a:headEnd type="none" w="med" len="med"/>
+                      <a:tailEnd type="none" w="med" len="med"/>
+                    </a:lnL>
+                    <a:lnR w="9525" cap="flat" cmpd="sng" algn="ctr">
+                      <a:solidFill>
+                        <a:srgbClr val="DCE3EC"/>
+                      </a:solidFill>
+                      <a:prstDash val="solid"/>
+                      <a:round/>
+                      <a:headEnd type="none" w="med" len="med"/>
+                      <a:tailEnd type="none" w="med" len="med"/>
+                    </a:lnR>
+                    <a:lnT w="9525" cap="flat" cmpd="sng" algn="ctr">
+                      <a:solidFill>
+                        <a:srgbClr val="DCE3EC"/>
+                      </a:solidFill>
+                      <a:prstDash val="solid"/>
+                      <a:round/>
+                      <a:headEnd type="none" w="med" len="med"/>
+                      <a:tailEnd type="none" w="med" len="med"/>
+                    </a:lnT>
+                    <a:lnB w="9525" cap="flat" cmpd="sng" algn="ctr">
+                      <a:solidFill>
+                        <a:srgbClr val="DCE3EC"/>
+                      </a:solidFill>
+                      <a:prstDash val="solid"/>
+                      <a:round/>
+                      <a:headEnd type="none" w="med" len="med"/>
+                      <a:tailEnd type="none" w="med" len="med"/>
+                    </a:lnB>
+                    <a:solidFill>
+                      <a:srgbClr val="FFFFFF"/>
+                    </a:solidFill>
+                  </a:tcPr>
+                </a:tc>
+                <a:tc>
+                  <a:txBody>
+                    <a:bodyPr/>
+                    <a:lstStyle/>
+                    <a:p>
+                      <a:pPr indent="0" marL="0">
+                        <a:buNone/>
+                      </a:pPr>
+                      <a:r>
+                        <a:rPr lang="en-US" sz="1200" dirty="0">
+                          <a:solidFill>
+                            <a:srgbClr val="3B4656"/>
+                          </a:solidFill>
+                          <a:latin typeface="Calibri" pitchFamily="34" charset="0"/>
+                          <a:ea typeface="Calibri" pitchFamily="34" charset="-122"/>
+                          <a:cs typeface="Calibri" pitchFamily="34" charset="-120"/>
+                        </a:rPr>
+                        <a:t>mint the skills a run proved · the evolution queue (propose mode)</a:t>
+                      </a:r>
+                      <a:endParaRPr lang="en-US" sz="1200" dirty="0">
+                        <a:latin typeface="Calibri" charset="0"/>
+                        <a:ea typeface="Calibri" charset="0"/>
+                        <a:cs typeface="Calibri" charset="0"/>
+                      </a:endParaRPr>
+                    </a:p>
+                  </a:txBody>
+                  <a:tcPr marL="54864" marR="54864" marT="54864" marB="54864" anchor="ctr">
+                    <a:lnL w="9525" cap="flat" cmpd="sng" algn="ctr">
+                      <a:solidFill>
+                        <a:srgbClr val="DCE3EC"/>
+                      </a:solidFill>
+                      <a:prstDash val="solid"/>
+                      <a:round/>
+                      <a:headEnd type="none" w="med" len="med"/>
+                      <a:tailEnd type="none" w="med" len="med"/>
+                    </a:lnL>
+                    <a:lnR w="9525" cap="flat" cmpd="sng" algn="ctr">
+                      <a:solidFill>
+                        <a:srgbClr val="DCE3EC"/>
+                      </a:solidFill>
+                      <a:prstDash val="solid"/>
+                      <a:round/>
+                      <a:headEnd type="none" w="med" len="med"/>
+                      <a:tailEnd type="none" w="med" len="med"/>
+                    </a:lnR>
+                    <a:lnT w="9525" cap="flat" cmpd="sng" algn="ctr">
+                      <a:solidFill>
+                        <a:srgbClr val="DCE3EC"/>
+                      </a:solidFill>
+                      <a:prstDash val="solid"/>
+                      <a:round/>
+                      <a:headEnd type="none" w="med" len="med"/>
+                      <a:tailEnd type="none" w="med" len="med"/>
+                    </a:lnT>
+                    <a:lnB w="9525" cap="flat" cmpd="sng" algn="ctr">
+                      <a:solidFill>
+                        <a:srgbClr val="DCE3EC"/>
+                      </a:solidFill>
+                      <a:prstDash val="solid"/>
+                      <a:round/>
+                      <a:headEnd type="none" w="med" len="med"/>
+                      <a:tailEnd type="none" w="med" len="med"/>
+                    </a:lnB>
+                    <a:solidFill>
+                      <a:srgbClr val="FFFFFF"/>
+                    </a:solidFill>
+                  </a:tcPr>
+                </a:tc>
+              </a:tr>
+              <a:tr h="393192">
                 <a:tc>
                   <a:txBody>
                     <a:bodyPr/>
@@ -15337,7 +15517,7 @@
                   </a:tcPr>
                 </a:tc>
               </a:tr>
-              <a:tr h="429768">
+              <a:tr h="393192">
                 <a:tc>
                   <a:txBody>
                     <a:bodyPr/>
@@ -15355,7 +15535,7 @@
                           <a:ea typeface="Courier New" pitchFamily="34" charset="-122"/>
                           <a:cs typeface="Courier New" pitchFamily="34" charset="-120"/>
                         </a:rPr>
-                        <a:t>agent-one board · init · version</a:t>
+                        <a:t>agent-one board · init · install</a:t>
                       </a:r>
                       <a:endParaRPr lang="en-US" sz="1100" dirty="0">
                         <a:latin typeface="Courier New" charset="0"/>
@@ -15423,7 +15603,7 @@
                           <a:ea typeface="Calibri" pitchFamily="34" charset="-122"/>
                           <a:cs typeface="Calibri" pitchFamily="34" charset="-120"/>
                         </a:rPr>
-                        <a:t>the dashboard alone · onboard a workspace · build stamp</a:t>
+                        <a:t>the dashboard alone · found a workspace (light · medium · complex) · the policy inside Claude Code</a:t>
                       </a:r>
                       <a:endParaRPr lang="en-US" sz="1200" dirty="0">
                         <a:latin typeface="Calibri" charset="0"/>
@@ -15628,7 +15808,7 @@
                 <a:ea typeface="Courier New" pitchFamily="34" charset="-122"/>
                 <a:cs typeface="Courier New" pitchFamily="34" charset="-120"/>
               </a:rPr>
-              <a:t>  run       run one ask to its end: run [--json] [--forma…</a:t>
+              <a:t>  dash      a live session in the browser: prompt, the ne…</a:t>
             </a:r>
             <a:endParaRPr lang="en-US" sz="850" dirty="0"/>
           </a:p>
@@ -15648,7 +15828,7 @@
                 <a:ea typeface="Courier New" pitchFamily="34" charset="-122"/>
                 <a:cs typeface="Courier New" pitchFamily="34" charset="-120"/>
               </a:rPr>
-              <a:t>  resume    resume a session: resume &lt;id&gt; [ask]</a:t>
+              <a:t>  run       run one ask to its end: run [--json] [--forma…</a:t>
             </a:r>
             <a:endParaRPr lang="en-US" sz="850" dirty="0"/>
           </a:p>
@@ -15668,7 +15848,7 @@
                 <a:ea typeface="Courier New" pitchFamily="34" charset="-122"/>
                 <a:cs typeface="Courier New" pitchFamily="34" charset="-120"/>
               </a:rPr>
-              <a:t>  sessions  list the sessions of this workspace</a:t>
+              <a:t>  resume    resume a session: resume &lt;id&gt; [ask]</a:t>
             </a:r>
             <a:endParaRPr lang="en-US" sz="850" dirty="0"/>
           </a:p>
@@ -15688,7 +15868,7 @@
                 <a:ea typeface="Courier New" pitchFamily="34" charset="-122"/>
                 <a:cs typeface="Courier New" pitchFamily="34" charset="-120"/>
               </a:rPr>
-              <a:t>  status    the honesty rule and the instrument board</a:t>
+              <a:t>  goal      work to a goal until a command proves it: goa…</a:t>
             </a:r>
             <a:endParaRPr lang="en-US" sz="850" dirty="0"/>
           </a:p>
@@ -15708,7 +15888,7 @@
                 <a:ea typeface="Courier New" pitchFamily="34" charset="-122"/>
                 <a:cs typeface="Courier New" pitchFamily="34" charset="-120"/>
               </a:rPr>
-              <a:t>  config    config show [--yaml] | explain | check | path…</a:t>
+              <a:t>  review    two reviewers on two models, one merged short…</a:t>
             </a:r>
             <a:endParaRPr lang="en-US" sz="850" dirty="0"/>
           </a:p>
@@ -15728,7 +15908,7 @@
                 <a:ea typeface="Courier New" pitchFamily="34" charset="-122"/>
                 <a:cs typeface="Courier New" pitchFamily="34" charset="-120"/>
               </a:rPr>
-              <a:t>  memory    the memory instrument (status, index, recall,…</a:t>
+              <a:t>  handoff   write a handoff for a fresh session: handoff …</a:t>
             </a:r>
             <a:endParaRPr lang="en-US" sz="850" dirty="0"/>
           </a:p>
@@ -15748,7 +15928,7 @@
                 <a:ea typeface="Courier New" pitchFamily="34" charset="-122"/>
                 <a:cs typeface="Courier New" pitchFamily="34" charset="-120"/>
               </a:rPr>
-              <a:t>  toolbox   the toolbox instrument (index, brief, pick, l…</a:t>
+              <a:t>  sessions  list the sessions of this workspace</a:t>
             </a:r>
             <a:endParaRPr lang="en-US" sz="850" dirty="0"/>
           </a:p>
@@ -15768,7 +15948,7 @@
                 <a:ea typeface="Courier New" pitchFamily="34" charset="-122"/>
                 <a:cs typeface="Courier New" pitchFamily="34" charset="-120"/>
               </a:rPr>
-              <a:t>  onto      the ontology (check, project, query)</a:t>
+              <a:t>  status    every reading — models, sandbox, guard, memor…</a:t>
             </a:r>
             <a:endParaRPr lang="en-US" sz="850" dirty="0"/>
           </a:p>
@@ -15788,7 +15968,7 @@
                 <a:ea typeface="Courier New" pitchFamily="34" charset="-122"/>
                 <a:cs typeface="Courier New" pitchFamily="34" charset="-120"/>
               </a:rPr>
-              <a:t>  usage     the usage journal: usage [--session &lt;id&gt;] [--…</a:t>
+              <a:t>  config    config show [--yaml] | explain | check | path…</a:t>
             </a:r>
             <a:endParaRPr lang="en-US" sz="850" dirty="0"/>
           </a:p>
@@ -15808,7 +15988,7 @@
                 <a:ea typeface="Courier New" pitchFamily="34" charset="-122"/>
                 <a:cs typeface="Courier New" pitchFamily="34" charset="-120"/>
               </a:rPr>
-              <a:t>  bench     a fixed task set on every configured model (m…</a:t>
+              <a:t>  memory    the memory instrument (status, index, recall,…</a:t>
             </a:r>
             <a:endParaRPr lang="en-US" sz="850" dirty="0"/>
           </a:p>
@@ -15828,7 +16008,7 @@
                 <a:ea typeface="Courier New" pitchFamily="34" charset="-122"/>
                 <a:cs typeface="Courier New" pitchFamily="34" charset="-120"/>
               </a:rPr>
-              <a:t>  selftest  every package's selftest, one @S PASS n checks</a:t>
+              <a:t>  toolbox   the toolbox instrument (index, brief, pick, l…</a:t>
             </a:r>
             <a:endParaRPr lang="en-US" sz="850" dirty="0"/>
           </a:p>
@@ -15848,7 +16028,7 @@
                 <a:ea typeface="Courier New" pitchFamily="34" charset="-122"/>
                 <a:cs typeface="Courier New" pitchFamily="34" charset="-120"/>
               </a:rPr>
-              <a:t>  init      found a workspace here: init [--bench]</a:t>
+              <a:t>  onto      the ontology (check, project, query)</a:t>
             </a:r>
             <a:endParaRPr lang="en-US" sz="850" dirty="0"/>
           </a:p>
@@ -15868,7 +16048,7 @@
                 <a:ea typeface="Courier New" pitchFamily="34" charset="-122"/>
                 <a:cs typeface="Courier New" pitchFamily="34" charset="-120"/>
               </a:rPr>
-              <a:t>  board     serve the board without a session</a:t>
+              <a:t>  evolve    the evolution queue (policy.evolution, propos…</a:t>
             </a:r>
             <a:endParaRPr lang="en-US" sz="850" dirty="0"/>
           </a:p>
@@ -15888,7 +16068,7 @@
                 <a:ea typeface="Courier New" pitchFamily="34" charset="-122"/>
                 <a:cs typeface="Courier New" pitchFamily="34" charset="-120"/>
               </a:rPr>
-              <a:t>  version   print the version</a:t>
+              <a:t>  forge     the forge working notes — the drafts subagent…</a:t>
             </a:r>
             <a:endParaRPr lang="en-US" sz="850" dirty="0"/>
           </a:p>
@@ -15908,7 +16088,7 @@
                 <a:ea typeface="Courier New" pitchFamily="34" charset="-122"/>
                 <a:cs typeface="Courier New" pitchFamily="34" charset="-120"/>
               </a:rPr>
-              <a:t>  help      this list</a:t>
+              <a:t>  housekeep the chain policy: audit member homes and link…</a:t>
             </a:r>
             <a:endParaRPr lang="en-US" sz="850" dirty="0"/>
           </a:p>
@@ -16211,7 +16391,7 @@
                 <a:ea typeface="Courier New" pitchFamily="34" charset="-122"/>
                 <a:cs typeface="Courier New" pitchFamily="34" charset="-120"/>
               </a:rPr>
-              <a:t>tools off: webfetch — disabled by tools.webfetch.enabled in ~/demo/.agent-one/config.yaml:17</a:t>
+              <a:t>tools off: webfetch — disabled by tools.webfetch.enabled in ~/demo/.agent-one/config.yaml:8</a:t>
             </a:r>
             <a:endParaRPr lang="en-US" sz="950" dirty="0"/>
           </a:p>
@@ -16231,7 +16411,7 @@
                 <a:ea typeface="Courier New" pitchFamily="34" charset="-122"/>
                 <a:cs typeface="Courier New" pitchFamily="34" charset="-120"/>
               </a:rPr>
-              <a:t>ranks: orchestrator [rankSet: extend] ·  auditor (ephemeral, role judge) ·  coord (ephemeral, role drafter) ·  domain (gate,…</a:t>
+              <a:t>ranks: orchestrator [rankSet: extend] ·  auditor (role judge) ·  coord (role drafter) ·  domain (gate, sideways, role judge)…</a:t>
             </a:r>
             <a:endParaRPr lang="en-US" sz="950" dirty="0"/>
           </a:p>
@@ -16251,7 +16431,7 @@
                 <a:ea typeface="Courier New" pitchFamily="34" charset="-122"/>
                 <a:cs typeface="Courier New" pitchFamily="34" charset="-120"/>
               </a:rPr>
-              <a:t>model default  vllm/fake/vllm-coder  ~/demo/.agent-one/config.yaml:11</a:t>
+              <a:t>model default  vllm/fake/vllm-coder  ~/demo/.agent-one/config.yaml:6</a:t>
             </a:r>
             <a:endParaRPr lang="en-US" sz="950" dirty="0"/>
           </a:p>
@@ -16271,7 +16451,7 @@
                 <a:ea typeface="Courier New" pitchFamily="34" charset="-122"/>
                 <a:cs typeface="Courier New" pitchFamily="34" charset="-120"/>
               </a:rPr>
-              <a:t>model role analyst  vllm/fake/vllm-coder  ~/demo/.agent-one/config.yaml:11</a:t>
+              <a:t>model role analyst  vllm/fake/vllm-coder  ~/demo/.agent-one/config.yaml:6</a:t>
             </a:r>
             <a:endParaRPr lang="en-US" sz="950" dirty="0"/>
           </a:p>
@@ -16291,7 +16471,7 @@
                 <a:ea typeface="Courier New" pitchFamily="34" charset="-122"/>
                 <a:cs typeface="Courier New" pitchFamily="34" charset="-120"/>
               </a:rPr>
-              <a:t>model role judge  vllm/fake/vllm-coder  ~/demo/.agent-one/config.yaml:11</a:t>
+              <a:t>model role judge  vllm/fake/vllm-coder  ~/demo/.agent-one/config.yaml:6</a:t>
             </a:r>
             <a:endParaRPr lang="en-US" sz="950" dirty="0"/>
           </a:p>
@@ -16311,7 +16491,7 @@
                 <a:ea typeface="Courier New" pitchFamily="34" charset="-122"/>
                 <a:cs typeface="Courier New" pitchFamily="34" charset="-120"/>
               </a:rPr>
-              <a:t>model role drafter  vllm/fake/vllm-coder  ~/demo/.agent-one/config.yaml:11</a:t>
+              <a:t>model role drafter  vllm/fake/vllm-coder  ~/demo/.agent-one/config.yaml:6</a:t>
             </a:r>
             <a:endParaRPr lang="en-US" sz="950" dirty="0"/>
           </a:p>
@@ -16331,7 +16511,7 @@
                 <a:ea typeface="Courier New" pitchFamily="34" charset="-122"/>
                 <a:cs typeface="Courier New" pitchFamily="34" charset="-120"/>
               </a:rPr>
-              <a:t>model rank  coord  vllm/fake/vllm-coder  ~/demo/.agent-one/config.yaml:11</a:t>
+              <a:t>model rank  coord → drafter vllm/fake/vllm-coder  ~/demo/.agent-one/config.yaml:6</a:t>
             </a:r>
             <a:endParaRPr lang="en-US" sz="950" dirty="0"/>
           </a:p>
@@ -16351,7 +16531,7 @@
                 <a:ea typeface="Courier New" pitchFamily="34" charset="-122"/>
                 <a:cs typeface="Courier New" pitchFamily="34" charset="-120"/>
               </a:rPr>
-              <a:t>model rank  domain  vllm/fake/vllm-coder  ~/demo/.agent-one/config.yaml:11</a:t>
+              <a:t>model rank  domain → judge vllm/fake/vllm-coder  ~/demo/.agent-one/config.yaml:6</a:t>
             </a:r>
             <a:endParaRPr lang="en-US" sz="950" dirty="0"/>
           </a:p>
@@ -16371,7 +16551,7 @@
                 <a:ea typeface="Courier New" pitchFamily="34" charset="-122"/>
                 <a:cs typeface="Courier New" pitchFamily="34" charset="-120"/>
               </a:rPr>
-              <a:t>model rank  zone  vllm/fake/vllm-coder  ~/demo/.agent-one/config.yaml:11</a:t>
+              <a:t>model rank  zone → analyst vllm/fake/vllm-coder  ~/demo/.agent-one/config.yaml:6</a:t>
             </a:r>
             <a:endParaRPr lang="en-US" sz="950" dirty="0"/>
           </a:p>
@@ -16391,7 +16571,7 @@
                 <a:ea typeface="Courier New" pitchFamily="34" charset="-122"/>
                 <a:cs typeface="Courier New" pitchFamily="34" charset="-120"/>
               </a:rPr>
-              <a:t>model rank  service  vllm/fake/vllm-coder  ~/demo/.agent-one/config.yaml:11</a:t>
+              <a:t>model rank  service → judge vllm/fake/vllm-coder  ~/demo/.agent-one/config.yaml:6</a:t>
             </a:r>
             <a:endParaRPr lang="en-US" sz="950" dirty="0"/>
           </a:p>
@@ -16411,7 +16591,7 @@
                 <a:ea typeface="Courier New" pitchFamily="34" charset="-122"/>
                 <a:cs typeface="Courier New" pitchFamily="34" charset="-120"/>
               </a:rPr>
-              <a:t>model rank  principal-coordinator vllm/fake/vllm-coder  ~/demo/.agent-one/config.yaml:11</a:t>
+              <a:t>model rank  principal-coordinator → drafter vllm/fake/vllm-coder  ~/demo/.agent-one/config.yaml:6</a:t>
             </a:r>
             <a:endParaRPr lang="en-US" sz="950" dirty="0"/>
           </a:p>
@@ -16431,7 +16611,7 @@
                 <a:ea typeface="Courier New" pitchFamily="34" charset="-122"/>
                 <a:cs typeface="Courier New" pitchFamily="34" charset="-120"/>
               </a:rPr>
-              <a:t>model rank  principal-domain-owner vllm/fake/vllm-coder  ~/demo/.agent-one/config.yaml:11</a:t>
+              <a:t>model rank  principal-domain-owner → judge vllm/fake/vllm-coder  ~/demo/.agent-one/config.yaml:6</a:t>
             </a:r>
             <a:endParaRPr lang="en-US" sz="950" dirty="0"/>
           </a:p>
@@ -16451,7 +16631,7 @@
                 <a:ea typeface="Courier New" pitchFamily="34" charset="-122"/>
                 <a:cs typeface="Courier New" pitchFamily="34" charset="-120"/>
               </a:rPr>
-              <a:t>model rank  auditor  vllm/fake/vllm-coder  ~/demo/.agent-one/config.yaml:11</a:t>
+              <a:t>model rank  auditor → judge vllm/fake/vllm-coder  ~/demo/.agent-one/config.yaml:6</a:t>
             </a:r>
             <a:endParaRPr lang="en-US" sz="950" dirty="0"/>
           </a:p>
@@ -16471,7 +16651,7 @@
                 <a:ea typeface="Courier New" pitchFamily="34" charset="-122"/>
                 <a:cs typeface="Courier New" pitchFamily="34" charset="-120"/>
               </a:rPr>
-              <a:t>model task  drain  vllm/fake/vllm-coder  ~/demo/.agent-one/config.yaml:11</a:t>
+              <a:t>model task  drain  vllm/fake/vllm-coder  ~/demo/.agent-one/config.yaml:6</a:t>
             </a:r>
             <a:endParaRPr lang="en-US" sz="950" dirty="0"/>
           </a:p>
@@ -16491,7 +16671,7 @@
                 <a:ea typeface="Courier New" pitchFamily="34" charset="-122"/>
                 <a:cs typeface="Courier New" pitchFamily="34" charset="-120"/>
               </a:rPr>
-              <a:t>model task  gate  vllm/fake/vllm-coder  ~/demo/.agent-one/config.yaml:11</a:t>
+              <a:t>model task  gate  vllm/fake/vllm-coder  ~/demo/.agent-one/config.yaml:6</a:t>
             </a:r>
             <a:endParaRPr lang="en-US" sz="950" dirty="0"/>
           </a:p>
@@ -16511,7 +16691,7 @@
                 <a:ea typeface="Courier New" pitchFamily="34" charset="-122"/>
                 <a:cs typeface="Courier New" pitchFamily="34" charset="-120"/>
               </a:rPr>
-              <a:t>model task  log  vllm/fake/vllm-coder  ~/demo/.agent-one/config.yaml:11</a:t>
+              <a:t>model task  log  vllm/fake/vllm-coder  ~/demo/.agent-one/config.yaml:6</a:t>
             </a:r>
             <a:endParaRPr lang="en-US" sz="950" dirty="0"/>
           </a:p>
@@ -16531,7 +16711,7 @@
                 <a:ea typeface="Courier New" pitchFamily="34" charset="-122"/>
                 <a:cs typeface="Courier New" pitchFamily="34" charset="-120"/>
               </a:rPr>
-              <a:t>model task  bench  vllm/fake/vllm-coder  ~/demo/.agent-one/config.yaml:11</a:t>
+              <a:t>model task  bench  vllm/fake/vllm-coder  ~/demo/.agent-one/config.yaml:6</a:t>
             </a:r>
             <a:endParaRPr lang="en-US" sz="950" dirty="0"/>
           </a:p>
@@ -16571,7 +16751,7 @@
                 <a:ea typeface="Courier New" pitchFamily="34" charset="-122"/>
                 <a:cs typeface="Courier New" pitchFamily="34" charset="-120"/>
               </a:rPr>
-              <a:t>compaction: drain · passes pointerize,trimSpent,unsaid,workingNotes,episode,verify</a:t>
+              <a:t>guard: 33 patterns (2 sources)</a:t>
             </a:r>
             <a:endParaRPr lang="en-US" sz="950" dirty="0"/>
           </a:p>
@@ -16591,7 +16771,7 @@
                 <a:ea typeface="Courier New" pitchFamily="34" charset="-122"/>
                 <a:cs typeface="Courier New" pitchFamily="34" charset="-120"/>
               </a:rPr>
-              <a:t>budget session: off</a:t>
+              <a:t>compaction: drain · passes pointerize,trimSpent,unsaid,workingNotes,episode,verify</a:t>
             </a:r>
             <a:endParaRPr lang="en-US" sz="950" dirty="0"/>
           </a:p>
@@ -16611,7 +16791,7 @@
                 <a:ea typeface="Courier New" pitchFamily="34" charset="-122"/>
                 <a:cs typeface="Courier New" pitchFamily="34" charset="-120"/>
               </a:rPr>
-              <a:t>budget subagent: off</a:t>
+              <a:t>budget session: off</a:t>
             </a:r>
             <a:endParaRPr lang="en-US" sz="950" dirty="0"/>
           </a:p>
@@ -16631,7 +16811,7 @@
                 <a:ea typeface="Courier New" pitchFamily="34" charset="-122"/>
                 <a:cs typeface="Courier New" pitchFamily="34" charset="-120"/>
               </a:rPr>
-              <a:t>workspace: ~/demo · agent-one · 1 members · 0 skills · 4 commands · 1 foreign agents</a:t>
+              <a:t>budget subagent: off</a:t>
             </a:r>
             <a:endParaRPr lang="en-US" sz="950" dirty="0"/>
           </a:p>

</xml_diff>